<commit_message>
Deck: closing slide with the GitHub link; drop judge Q&A and the old Day 1 pitch files
</commit_message>
<xml_diff>
--- a/pitch/CallShield_Final.pptx
+++ b/pitch/CallShield_Final.pptx
@@ -11,9 +11,10 @@
     <p:sldId id="259" r:id="rId5"/>
     <p:sldId id="260" r:id="rId6"/>
     <p:sldId id="261" r:id="rId7"/>
+    <p:sldId id="262" r:id="rId8"/>
   </p:sldIdLst>
   <p:notesMasterIdLst>
-    <p:notesMasterId r:id="rId8"/>
+    <p:notesMasterId r:id="rId9"/>
   </p:notesMasterIdLst>
   <p:sldSz cx="12192000" cy="6858000"/>
   <p:notesSz cx="6858000" cy="12192000"/>
@@ -112,34 +113,39 @@
   <p:extLst>
     <p:ext uri="{521415D9-36F7-43E2-AB2F-B90AF26B5E84}">
       <p14:sectionLst xmlns:p14="http://schemas.microsoft.com/office/powerpoint/2010/main">
-        <p14:section name="Title" id="{761a116b-0cdc-7992-e2f6-a1a5199a9776}">
+        <p14:section name="Title" id="{0a0f563f-e9c7-2b4c-a9d2-b500bd12a554}">
           <p14:sldIdLst>
             <p14:sldId id="256"/>
           </p14:sldIdLst>
         </p14:section>
-        <p14:section name="Problem" id="{6db9f868-1c4f-a11b-d154-381ac66760ee}">
+        <p14:section name="Problem" id="{79129795-2249-b898-4739-e29239ecd953}">
           <p14:sldIdLst>
             <p14:sldId id="257"/>
           </p14:sldIdLst>
         </p14:section>
-        <p14:section name="Solution" id="{38e8c234-8ddf-f626-d6d2-3f33a95658c6}">
+        <p14:section name="Solution" id="{cc36d688-5e62-73ec-8576-9b0d7fe8ad68}">
           <p14:sldIdLst>
             <p14:sldId id="258"/>
           </p14:sldIdLst>
         </p14:section>
-        <p14:section name="DetectifAI" id="{58f6b46b-aab3-f042-5266-29c3475c6353}">
+        <p14:section name="DetectifAI" id="{a6454d83-fa13-f2ba-7b35-700632f9e1ee}">
           <p14:sldIdLst>
             <p14:sldId id="259"/>
           </p14:sldIdLst>
         </p14:section>
-        <p14:section name="Impact" id="{d96a426e-f252-c417-21c0-18b7f9fdda5a}">
+        <p14:section name="Impact" id="{1f3cd05b-071e-8926-a4d9-f9d811f0377a}">
           <p14:sldIdLst>
             <p14:sldId id="260"/>
           </p14:sldIdLst>
         </p14:section>
-        <p14:section name="Scale" id="{0265aa8f-945d-5caf-cc90-f15fb11a410c}">
+        <p14:section name="Scale" id="{1489eaaa-4f89-54fe-408a-058b478f0b88}">
           <p14:sldIdLst>
             <p14:sldId id="261"/>
+          </p14:sldIdLst>
+        </p14:section>
+        <p14:section name="Code" id="{6edff059-9852-c88e-5a65-9d15ff1f42ab}">
+          <p14:sldIdLst>
+            <p14:sldId id="262"/>
           </p14:sldIdLst>
         </p14:section>
       </p14:sectionLst>
@@ -1284,6 +1290,94 @@
             <a:fld id="{F7021451-1387-4CA6-816F-3879F97B5CBC}" type="slidenum">
               <a:rPr lang="en-US"/>
               <a:t>6</a:t>
+            </a:fld>
+            <a:endParaRPr lang="en-US"/>
+          </a:p>
+        </p:txBody>
+      </p:sp>
+    </p:spTree>
+    <p:extLst>
+      <p:ext uri="{BB962C8B-B14F-4D97-AF65-F5344CB8AC3E}">
+        <p14:creationId xmlns:p14="http://schemas.microsoft.com/office/powerpoint/2010/main" val="1024086991"/>
+      </p:ext>
+    </p:extLst>
+  </p:cSld>
+  <p:clrMapOvr>
+    <a:masterClrMapping/>
+  </p:clrMapOvr>
+</p:notes>
+</file>
+
+<file path=ppt/notesSlides/notesSlide7.xml><?xml version="1.0" encoding="utf-8"?>
+<p:notes xmlns:a="http://schemas.openxmlformats.org/drawingml/2006/main" xmlns:r="http://schemas.openxmlformats.org/officeDocument/2006/relationships" xmlns:p="http://schemas.openxmlformats.org/presentationml/2006/main">
+  <p:cSld>
+    <p:spTree>
+      <p:nvGrpSpPr>
+        <p:cNvPr id="1" name=""/>
+        <p:cNvGrpSpPr/>
+        <p:nvPr/>
+      </p:nvGrpSpPr>
+      <p:grpSpPr>
+        <a:xfrm>
+          <a:off x="0" y="0"/>
+          <a:ext cx="0" cy="0"/>
+          <a:chOff x="0" y="0"/>
+          <a:chExt cx="0" cy="0"/>
+        </a:xfrm>
+      </p:grpSpPr>
+      <p:sp>
+        <p:nvSpPr>
+          <p:cNvPr id="2" name="Slide Image Placeholder 1"/>
+          <p:cNvSpPr>
+            <a:spLocks noGrp="1" noRot="1" noChangeAspect="1"/>
+          </p:cNvSpPr>
+          <p:nvPr>
+            <p:ph type="sldImg"/>
+          </p:nvPr>
+        </p:nvSpPr>
+        <p:spPr/>
+      </p:sp>
+      <p:sp>
+        <p:nvSpPr>
+          <p:cNvPr id="3" name="Notes Placeholder 2"/>
+          <p:cNvSpPr>
+            <a:spLocks noGrp="1"/>
+          </p:cNvSpPr>
+          <p:nvPr>
+            <p:ph type="body" idx="1"/>
+          </p:nvPr>
+        </p:nvSpPr>
+        <p:spPr/>
+        <p:txBody>
+          <a:bodyPr/>
+          <a:lstStyle/>
+          <a:p>
+            <a:r>
+              <a:rPr lang="en-US" dirty="0"/>
+              <a:t>Thank you. All of the code, the Android app, the receive screen and the Attack Lab, is public at github.com/Nazeef1/callshield.</a:t>
+            </a:r>
+            <a:endParaRPr lang="en-US" dirty="0"/>
+          </a:p>
+        </p:txBody>
+      </p:sp>
+      <p:sp>
+        <p:nvSpPr>
+          <p:cNvPr id="4" name="Slide Number Placeholder 3"/>
+          <p:cNvSpPr>
+            <a:spLocks noGrp="1"/>
+          </p:cNvSpPr>
+          <p:nvPr>
+            <p:ph type="sldNum" sz="quarter" idx="10"/>
+          </p:nvPr>
+        </p:nvSpPr>
+        <p:spPr/>
+        <p:txBody>
+          <a:bodyPr/>
+          <a:lstStyle/>
+          <a:p>
+            <a:fld id="{F7021451-1387-4CA6-816F-3879F97B5CBC}" type="slidenum">
+              <a:rPr lang="en-US"/>
+              <a:t>7</a:t>
             </a:fld>
             <a:endParaRPr lang="en-US"/>
           </a:p>
@@ -5667,6 +5761,233 @@
               <a:t>6</a:t>
             </a:fld>
             <a:endParaRPr lang="en-US"/>
+          </a:p>
+        </p:txBody>
+      </p:sp>
+    </p:spTree>
+  </p:cSld>
+  <p:clrMapOvr>
+    <a:masterClrMapping/>
+  </p:clrMapOvr>
+</p:sld>
+</file>
+
+<file path=ppt/slides/slide7.xml><?xml version="1.0" encoding="utf-8"?>
+<p:sld xmlns:a="http://schemas.openxmlformats.org/drawingml/2006/main" xmlns:r="http://schemas.openxmlformats.org/officeDocument/2006/relationships" xmlns:p="http://schemas.openxmlformats.org/presentationml/2006/main">
+  <p:cSld name="Slide 7">
+    <p:spTree>
+      <p:nvGrpSpPr>
+        <p:cNvPr id="1" name=""/>
+        <p:cNvGrpSpPr/>
+        <p:nvPr/>
+      </p:nvGrpSpPr>
+      <p:grpSpPr>
+        <a:xfrm>
+          <a:off x="0" y="0"/>
+          <a:ext cx="0" cy="0"/>
+          <a:chOff x="0" y="0"/>
+          <a:chExt cx="0" cy="0"/>
+        </a:xfrm>
+      </p:grpSpPr>
+      <p:pic>
+        <p:nvPicPr>
+          <p:cNvPr id="2" name="logo" descr="CallShield shield logo">    </p:cNvPr>
+          <p:cNvPicPr>
+            <a:picLocks noChangeAspect="1"/>
+          </p:cNvPicPr>
+          <p:nvPr/>
+        </p:nvPicPr>
+        <p:blipFill>
+          <a:blip r:embed="rId1"/>
+          <a:stretch>
+            <a:fillRect/>
+          </a:stretch>
+        </p:blipFill>
+        <p:spPr>
+          <a:xfrm>
+            <a:off x="658368" y="1417320"/>
+            <a:ext cx="914400" cy="914400"/>
+          </a:xfrm>
+          <a:prstGeom prst="rect">
+            <a:avLst/>
+          </a:prstGeom>
+        </p:spPr>
+      </p:pic>
+      <p:sp>
+        <p:nvSpPr>
+          <p:cNvPr id="3" name="thanks"/>
+          <p:cNvSpPr txBox="1"/>
+          <p:nvPr/>
+        </p:nvSpPr>
+        <p:spPr>
+          <a:xfrm>
+            <a:off x="822960" y="2514600"/>
+            <a:ext cx="8229600" cy="1005840"/>
+          </a:xfrm>
+          <a:prstGeom prst="rect">
+            <a:avLst/>
+          </a:prstGeom>
+          <a:noFill/>
+          <a:ln/>
+        </p:spPr>
+        <p:txBody>
+          <a:bodyPr wrap="square" lIns="0" tIns="0" rIns="0" bIns="0" rtlCol="0" anchor="ctr"/>
+          <a:lstStyle/>
+          <a:p>
+            <a:pPr indent="0" marL="0">
+              <a:buNone/>
+            </a:pPr>
+            <a:r>
+              <a:rPr lang="en-US" sz="5400" b="1" dirty="0">
+                <a:solidFill>
+                  <a:schemeClr val="bg1"/>
+                </a:solidFill>
+              </a:rPr>
+              <a:t>Thank you</a:t>
+            </a:r>
+            <a:endParaRPr lang="en-US" sz="5400" dirty="0"/>
+          </a:p>
+        </p:txBody>
+      </p:sp>
+      <p:sp>
+        <p:nvSpPr>
+          <p:cNvPr id="4" name="closing-line"/>
+          <p:cNvSpPr txBox="1"/>
+          <p:nvPr/>
+        </p:nvSpPr>
+        <p:spPr>
+          <a:xfrm>
+            <a:off x="822960" y="3520440"/>
+            <a:ext cx="10058400" cy="548640"/>
+          </a:xfrm>
+          <a:prstGeom prst="rect">
+            <a:avLst/>
+          </a:prstGeom>
+          <a:noFill/>
+          <a:ln/>
+        </p:spPr>
+        <p:txBody>
+          <a:bodyPr wrap="square" lIns="0" tIns="0" rIns="0" bIns="0" rtlCol="0" anchor="ctr"/>
+          <a:lstStyle/>
+          <a:p>
+            <a:pPr indent="0" marL="0">
+              <a:buNone/>
+            </a:pPr>
+            <a:r>
+              <a:rPr lang="en-US" sz="2000" dirty="0">
+                <a:solidFill>
+                  <a:schemeClr val="bg2"/>
+                </a:solidFill>
+              </a:rPr>
+              <a:t>A fraudster can copy your voice. CallShield makes sure it can’t move your money.</a:t>
+            </a:r>
+            <a:endParaRPr lang="en-US" sz="2000" dirty="0"/>
+          </a:p>
+        </p:txBody>
+      </p:sp>
+      <p:sp>
+        <p:nvSpPr>
+          <p:cNvPr id="5" name="repo-card"/>
+          <p:cNvSpPr/>
+          <p:nvPr/>
+        </p:nvSpPr>
+        <p:spPr>
+          <a:xfrm>
+            <a:off x="822960" y="4389120"/>
+            <a:ext cx="7863840" cy="960120"/>
+          </a:xfrm>
+          <a:prstGeom prst="roundRect">
+            <a:avLst>
+              <a:gd name="adj" fmla="val 11429"/>
+            </a:avLst>
+          </a:prstGeom>
+          <a:solidFill>
+            <a:schemeClr val="tx2"/>
+          </a:solidFill>
+          <a:ln w="9525">
+            <a:solidFill>
+              <a:schemeClr val="accent6"/>
+            </a:solidFill>
+            <a:prstDash val="solid"/>
+          </a:ln>
+        </p:spPr>
+      </p:sp>
+      <p:sp>
+        <p:nvSpPr>
+          <p:cNvPr id="6" name="Text 3"/>
+          <p:cNvSpPr txBox="1"/>
+          <p:nvPr/>
+        </p:nvSpPr>
+        <p:spPr>
+          <a:xfrm>
+            <a:off x="1097280" y="4526280"/>
+            <a:ext cx="1828800" cy="274320"/>
+          </a:xfrm>
+          <a:prstGeom prst="rect">
+            <a:avLst/>
+          </a:prstGeom>
+          <a:noFill/>
+          <a:ln/>
+        </p:spPr>
+        <p:txBody>
+          <a:bodyPr wrap="square" lIns="0" tIns="0" rIns="0" bIns="0" rtlCol="0" anchor="ctr"/>
+          <a:lstStyle/>
+          <a:p>
+            <a:pPr indent="0" marL="0">
+              <a:buNone/>
+            </a:pPr>
+            <a:r>
+              <a:rPr lang="en-US" sz="1100" b="1" spc="300" kern="0" dirty="0">
+                <a:solidFill>
+                  <a:schemeClr val="bg2"/>
+                </a:solidFill>
+              </a:rPr>
+              <a:t>CODE</a:t>
+            </a:r>
+            <a:endParaRPr lang="en-US" sz="1100" dirty="0"/>
+          </a:p>
+        </p:txBody>
+      </p:sp>
+      <p:sp>
+        <p:nvSpPr>
+          <p:cNvPr id="7" name="repo-link"/>
+          <p:cNvSpPr txBox="1"/>
+          <p:nvPr/>
+        </p:nvSpPr>
+        <p:spPr>
+          <a:xfrm>
+            <a:off x="1097280" y="4800600"/>
+            <a:ext cx="7406640" cy="457200"/>
+          </a:xfrm>
+          <a:prstGeom prst="rect">
+            <a:avLst/>
+          </a:prstGeom>
+          <a:noFill/>
+          <a:ln/>
+        </p:spPr>
+        <p:txBody>
+          <a:bodyPr wrap="square" lIns="0" tIns="0" rIns="0" bIns="0" rtlCol="0" anchor="ctr"/>
+          <a:lstStyle/>
+          <a:p>
+            <a:pPr indent="0" marL="0">
+              <a:buNone/>
+            </a:pPr>
+            <a:r>
+              <a:rPr lang="en-US" sz="2200" b="1" u="sng" dirty="0">
+                <a:solidFill>
+                  <a:schemeClr val="accent1"/>
+                </a:solidFill>
+                <a:hlinkClick r:id="rId2" invalidUrl="" action="" tgtFrame="" tooltip="" history="1" highlightClick="0" endSnd="0">
+                  <a:extLst>
+                    <a:ext uri="{A12FA001-AC4F-418D-AE19-62706E023703}">
+                      <ahyp:hlinkClr xmlns:ahyp="http://schemas.microsoft.com/office/drawing/2018/hyperlinkcolor" val="tx"/>
+                    </a:ext>
+                  </a:extLst>
+                </a:hlinkClick>
+              </a:rPr>
+              <a:t>github.com/Nazeef1/callshield</a:t>
+            </a:r>
+            <a:endParaRPr lang="en-US" sz="2200" dirty="0"/>
           </a:p>
         </p:txBody>
       </p:sp>

</xml_diff>

<commit_message>
Deck and README: Team 1, Zain Mahedi (lead) and Nazeef Ahsan Rafiqui
</commit_message>
<xml_diff>
--- a/pitch/CallShield_Final.pptx
+++ b/pitch/CallShield_Final.pptx
@@ -113,37 +113,37 @@
   <p:extLst>
     <p:ext uri="{521415D9-36F7-43E2-AB2F-B90AF26B5E84}">
       <p14:sectionLst xmlns:p14="http://schemas.microsoft.com/office/powerpoint/2010/main">
-        <p14:section name="Title" id="{0a0f563f-e9c7-2b4c-a9d2-b500bd12a554}">
+        <p14:section name="Title" id="{a18de098-9539-8a09-4900-9ca40ff7c307}">
           <p14:sldIdLst>
             <p14:sldId id="256"/>
           </p14:sldIdLst>
         </p14:section>
-        <p14:section name="Problem" id="{79129795-2249-b898-4739-e29239ecd953}">
+        <p14:section name="Problem" id="{6def30cb-1c83-3831-2bfd-0142e98bf114}">
           <p14:sldIdLst>
             <p14:sldId id="257"/>
           </p14:sldIdLst>
         </p14:section>
-        <p14:section name="Solution" id="{cc36d688-5e62-73ec-8576-9b0d7fe8ad68}">
+        <p14:section name="Solution" id="{7a278e63-42c5-ac6f-e5fc-ace1b0ea7dba}">
           <p14:sldIdLst>
             <p14:sldId id="258"/>
           </p14:sldIdLst>
         </p14:section>
-        <p14:section name="DetectifAI" id="{a6454d83-fa13-f2ba-7b35-700632f9e1ee}">
+        <p14:section name="DetectifAI" id="{dbec5cb7-973a-1489-163d-4a291491f7cc}">
           <p14:sldIdLst>
             <p14:sldId id="259"/>
           </p14:sldIdLst>
         </p14:section>
-        <p14:section name="Impact" id="{1f3cd05b-071e-8926-a4d9-f9d811f0377a}">
+        <p14:section name="Impact" id="{942a9df6-1032-af6f-ca6b-54eaa25e2ffe}">
           <p14:sldIdLst>
             <p14:sldId id="260"/>
           </p14:sldIdLst>
         </p14:section>
-        <p14:section name="Scale" id="{1489eaaa-4f89-54fe-408a-058b478f0b88}">
+        <p14:section name="Scale" id="{78be7081-ed90-118c-ba02-0cf8b8d05864}">
           <p14:sldIdLst>
             <p14:sldId id="261"/>
           </p14:sldIdLst>
         </p14:section>
-        <p14:section name="Code" id="{6edff059-9852-c88e-5a65-9d15ff1f42ab}">
+        <p14:section name="Code" id="{e2724c96-c65f-0814-aa3f-cae6b227e126}">
           <p14:sldIdLst>
             <p14:sldId id="262"/>
           </p14:sldIdLst>
@@ -2057,7 +2057,54 @@
       </p:sp>
       <p:sp>
         <p:nvSpPr>
-          <p:cNvPr id="6" name="event"/>
+          <p:cNvPr id="6" name="team"/>
+          <p:cNvSpPr txBox="1"/>
+          <p:nvPr/>
+        </p:nvSpPr>
+        <p:spPr>
+          <a:xfrm>
+            <a:off x="822960" y="5532120"/>
+            <a:ext cx="10515600" cy="365760"/>
+          </a:xfrm>
+          <a:prstGeom prst="rect">
+            <a:avLst/>
+          </a:prstGeom>
+          <a:noFill/>
+          <a:ln/>
+        </p:spPr>
+        <p:txBody>
+          <a:bodyPr wrap="square" lIns="0" tIns="0" rIns="0" bIns="0" rtlCol="0" anchor="ctr"/>
+          <a:lstStyle/>
+          <a:p>
+            <a:pPr indent="0" marL="0">
+              <a:buNone/>
+            </a:pPr>
+            <a:r>
+              <a:rPr lang="en-US" sz="1600" b="1" dirty="0">
+                <a:solidFill>
+                  <a:schemeClr val="accent1"/>
+                </a:solidFill>
+              </a:rPr>
+              <a:t>Team 1</a:t>
+            </a:r>
+            <a:pPr indent="0" marL="0">
+              <a:buNone/>
+            </a:pPr>
+            <a:r>
+              <a:rPr lang="en-US" sz="1600" dirty="0">
+                <a:solidFill>
+                  <a:schemeClr val="bg1"/>
+                </a:solidFill>
+              </a:rPr>
+              <a:t>   Zain Mahedi (lead)  ·  Nazeef Ahsan Rafiqui</a:t>
+            </a:r>
+            <a:endParaRPr lang="en-US" sz="1600" dirty="0"/>
+          </a:p>
+        </p:txBody>
+      </p:sp>
+      <p:sp>
+        <p:nvSpPr>
+          <p:cNvPr id="7" name="event"/>
           <p:cNvSpPr txBox="1"/>
           <p:nvPr/>
         </p:nvSpPr>

</xml_diff>